<commit_message>
fix(affiches): stations re-rendues Manrope + chip auto-elargi (brigade ne deborde plus); STATION JEU sur bergerie/pegase; verif systematique 42 docs (overflow 0, QR ok, no mail)
</commit_message>
<xml_diff>
--- a/admin/public/nds/kit-digital/nds/station-jeu_32x45_brigade-verte-1_editable.pptx
+++ b/admin/public/nds/kit-digital/nds/station-jeu_32x45_brigade-verte-1_editable.pptx
@@ -3146,8 +3146,8 @@
         </p:nvSpPr>
         <p:spPr>
           <a:xfrm>
-            <a:off x="8552446" y="870584"/>
-            <a:ext cx="2534508" cy="777613"/>
+            <a:off x="6126493" y="870584"/>
+            <a:ext cx="4960461" cy="777613"/>
           </a:xfrm>
           <a:prstGeom prst="roundRect">
             <a:avLst>

</xml_diff>